<commit_message>
feat: integrate AIGC dynamic synthesis, global blueprint   gate, and submodule drawingml compilation
</commit_message>
<xml_diff>
--- a/tests/test_out_aurora.pptx
+++ b/tests/test_out_aurora.pptx
@@ -10,9 +10,12 @@
     <p:sldId id="258" r:id="rId4"/>
     <p:sldId id="259" r:id="rId5"/>
     <p:sldId id="260" r:id="rId6"/>
+    <p:sldId id="261" r:id="rId7"/>
+    <p:sldId id="262" r:id="rId8"/>
+    <p:sldId id="263" r:id="rId9"/>
   </p:sldIdLst>
   <p:notesMasterIdLst>
-    <p:notesMasterId r:id="rId7"/>
+    <p:notesMasterId r:id="rId10"/>
   </p:notesMasterIdLst>
   <p:sldSz cx="12192000" cy="6858000"/>
   <p:notesSz cx="6858000" cy="12192000"/>
@@ -109,6 +112,333 @@
     </a:lvl9pPr>
   </p:defaultTextStyle>
 </p:presentation>
+</file>
+
+<file path=ppt/charts/chart5.xml><?xml version="1.0" encoding="utf-8"?>
+<c:chartSpace xmlns:c="http://schemas.openxmlformats.org/drawingml/2006/chart" xmlns:a="http://schemas.openxmlformats.org/drawingml/2006/main" xmlns:r="http://schemas.openxmlformats.org/officeDocument/2006/relationships">
+  <c:date1904 val="0"/>
+  <c:roundedCorners val="1"/>
+  <c:chart>
+    <c:autoTitleDeleted val="1"/>
+    <c:plotArea>
+      <c:layout/>
+      <c:barChart>
+        <c:barDir val="col"/>
+        <c:grouping val="clustered"/>
+        <c:varyColors val="0"/>
+        <c:ser>
+          <c:idx val="0"/>
+          <c:order val="0"/>
+          <c:tx>
+            <c:strRef>
+              <c:f>Sheet1!$B$1</c:f>
+              <c:strCache>
+                <c:ptCount val="1"/>
+                <c:pt idx="0">
+                  <c:v>Local Inference (ms)</c:v>
+                </c:pt>
+              </c:strCache>
+            </c:strRef>
+          </c:tx>
+          <c:spPr>
+            <a:solidFill>
+              <a:srgbClr val="D946EF"/>
+            </a:solidFill>
+            <a:effectLst/>
+          </c:spPr>
+          <c:invertIfNegative val="0"/>
+          <c:dLbls>
+            <c:numFmt formatCode="#,##0" sourceLinked="0"/>
+            <c:txPr>
+              <a:bodyPr/>
+              <a:lstStyle/>
+              <a:p>
+                <a:pPr>
+                  <a:defRPr b="0" i="0" strike="noStrike" sz="1200" u="none">
+                    <a:solidFill>
+                      <a:srgbClr val="000000"/>
+                    </a:solidFill>
+                    <a:latin typeface="Arial"/>
+                  </a:defRPr>
+                </a:pPr>
+              </a:p>
+            </c:txPr>
+            <c:showLegendKey val="0"/>
+            <c:showVal val="0"/>
+            <c:showCatName val="0"/>
+            <c:showSerName val="0"/>
+            <c:showPercent val="0"/>
+            <c:showBubbleSize val="0"/>
+            <c:showLeaderLines val="0"/>
+          </c:dLbls>
+          <c:cat>
+            <c:multiLvlStrRef>
+              <c:f>Sheet1!$A$2:$A$4</c:f>
+              <c:multiLvlStrCache>
+                <c:ptCount val="3"/>
+                <c:lvl>
+                  <c:pt idx="0">
+                    <c:v>Baseline VLA</c:v>
+                  </c:pt>
+                  <c:pt idx="1">
+                    <c:v>WAM Core</c:v>
+                  </c:pt>
+                  <c:pt idx="2">
+                    <c:v>WAM++ Optimized</c:v>
+                  </c:pt>
+                </c:lvl>
+              </c:multiLvlStrCache>
+            </c:multiLvlStrRef>
+          </c:cat>
+          <c:val>
+            <c:numRef>
+              <c:f>Sheet1!$B$2:$B$4</c:f>
+              <c:numCache>
+                <c:formatCode>General</c:formatCode>
+                <c:ptCount val="3"/>
+                <c:pt idx="0">
+                  <c:v>250</c:v>
+                </c:pt>
+                <c:pt idx="1">
+                  <c:v>16</c:v>
+                </c:pt>
+                <c:pt idx="2">
+                  <c:v>8</c:v>
+                </c:pt>
+              </c:numCache>
+            </c:numRef>
+          </c:val>
+        </c:ser>
+        <c:ser>
+          <c:idx val="1"/>
+          <c:order val="1"/>
+          <c:tx>
+            <c:strRef>
+              <c:f>Sheet1!$C$1</c:f>
+              <c:strCache>
+                <c:ptCount val="1"/>
+                <c:pt idx="0">
+                  <c:v>Remote Cloud API (ms)</c:v>
+                </c:pt>
+              </c:strCache>
+            </c:strRef>
+          </c:tx>
+          <c:spPr>
+            <a:solidFill>
+              <a:srgbClr val="7C3AED"/>
+            </a:solidFill>
+            <a:effectLst/>
+          </c:spPr>
+          <c:invertIfNegative val="0"/>
+          <c:dLbls>
+            <c:numFmt formatCode="#,##0" sourceLinked="0"/>
+            <c:txPr>
+              <a:bodyPr/>
+              <a:lstStyle/>
+              <a:p>
+                <a:pPr>
+                  <a:defRPr b="0" i="0" strike="noStrike" sz="1200" u="none">
+                    <a:solidFill>
+                      <a:srgbClr val="000000"/>
+                    </a:solidFill>
+                    <a:latin typeface="Arial"/>
+                  </a:defRPr>
+                </a:pPr>
+              </a:p>
+            </c:txPr>
+            <c:showLegendKey val="0"/>
+            <c:showVal val="0"/>
+            <c:showCatName val="0"/>
+            <c:showSerName val="0"/>
+            <c:showPercent val="0"/>
+            <c:showBubbleSize val="0"/>
+            <c:showLeaderLines val="0"/>
+          </c:dLbls>
+          <c:cat>
+            <c:multiLvlStrRef>
+              <c:f>Sheet1!$A$2:$A$4</c:f>
+              <c:multiLvlStrCache>
+                <c:ptCount val="3"/>
+                <c:lvl>
+                  <c:pt idx="0">
+                    <c:v>Baseline VLA</c:v>
+                  </c:pt>
+                  <c:pt idx="1">
+                    <c:v>WAM Core</c:v>
+                  </c:pt>
+                  <c:pt idx="2">
+                    <c:v>WAM++ Optimized</c:v>
+                  </c:pt>
+                </c:lvl>
+              </c:multiLvlStrCache>
+            </c:multiLvlStrRef>
+          </c:cat>
+          <c:val>
+            <c:numRef>
+              <c:f>Sheet1!$C$2:$C$4</c:f>
+              <c:numCache>
+                <c:formatCode>General</c:formatCode>
+                <c:ptCount val="3"/>
+                <c:pt idx="0">
+                  <c:v>850</c:v>
+                </c:pt>
+                <c:pt idx="1">
+                  <c:v>450</c:v>
+                </c:pt>
+                <c:pt idx="2">
+                  <c:v>380</c:v>
+                </c:pt>
+              </c:numCache>
+            </c:numRef>
+          </c:val>
+        </c:ser>
+        <c:dLbls>
+          <c:numFmt formatCode="#,##0" sourceLinked="0"/>
+          <c:txPr>
+            <a:bodyPr/>
+            <a:lstStyle/>
+            <a:p>
+              <a:pPr>
+                <a:defRPr b="0" i="0" strike="noStrike" sz="1200" u="none">
+                  <a:solidFill>
+                    <a:srgbClr val="000000"/>
+                  </a:solidFill>
+                  <a:latin typeface="Arial"/>
+                </a:defRPr>
+              </a:pPr>
+            </a:p>
+          </c:txPr>
+          <c:showLegendKey val="0"/>
+          <c:showVal val="0"/>
+          <c:showCatName val="0"/>
+          <c:showSerName val="0"/>
+          <c:showPercent val="0"/>
+          <c:showBubbleSize val="0"/>
+          <c:showLeaderLines val="0"/>
+        </c:dLbls>
+        <c:gapWidth val="150"/>
+        <c:overlap val="0"/>
+        <c:axId val="2094734554"/>
+        <c:axId val="2094734552"/>
+        <c:axId val="2094734556"/>
+      </c:barChart>
+      <c:catAx>
+        <c:axId val="2094734554"/>
+        <c:scaling>
+          <c:orientation val="minMax"/>
+        </c:scaling>
+        <c:delete val="0"/>
+        <c:axPos val="b"/>
+        <c:numFmt formatCode="General" sourceLinked="1"/>
+        <c:majorTickMark val="out"/>
+        <c:minorTickMark val="none"/>
+        <c:tickLblPos val="low"/>
+        <c:spPr>
+          <a:ln w="12700" cap="flat">
+            <a:solidFill>
+              <a:srgbClr val="E9D5FF"/>
+            </a:solidFill>
+            <a:prstDash val="solid"/>
+            <a:round/>
+          </a:ln>
+        </c:spPr>
+        <c:txPr>
+          <a:bodyPr/>
+          <a:lstStyle/>
+          <a:p>
+            <a:pPr>
+              <a:defRPr sz="1200" b="0" i="0" u="none" strike="noStrike">
+                <a:solidFill>
+                  <a:srgbClr val="4B5563"/>
+                </a:solidFill>
+                <a:latin typeface="Arial"/>
+              </a:defRPr>
+            </a:pPr>
+            <a:endParaRPr lang="en-US"/>
+          </a:p>
+        </c:txPr>
+        <c:crossAx val="2094734552"/>
+        <c:crosses val="autoZero"/>
+        <c:auto val="1"/>
+        <c:lblAlgn val="ctr"/>
+        <c:noMultiLvlLbl val="1"/>
+      </c:catAx>
+      <c:valAx>
+        <c:axId val="2094734552"/>
+        <c:scaling>
+          <c:orientation val="minMax"/>
+        </c:scaling>
+        <c:delete val="0"/>
+        <c:axPos val="l"/>
+        <c:majorGridlines>
+          <c:spPr>
+            <a:ln w="12700" cap="flat">
+              <a:solidFill>
+                <a:srgbClr val="888888"/>
+              </a:solidFill>
+              <a:prstDash val="solid"/>
+              <a:round/>
+            </a:ln>
+          </c:spPr>
+        </c:majorGridlines>
+        <c:numFmt formatCode="General" sourceLinked="0"/>
+        <c:majorTickMark val="out"/>
+        <c:minorTickMark val="none"/>
+        <c:tickLblPos val="nextTo"/>
+        <c:spPr>
+          <a:ln w="12700" cap="flat">
+            <a:solidFill>
+              <a:srgbClr val="E9D5FF"/>
+            </a:solidFill>
+            <a:prstDash val="solid"/>
+            <a:round/>
+          </a:ln>
+        </c:spPr>
+        <c:txPr>
+          <a:bodyPr/>
+          <a:lstStyle/>
+          <a:p>
+            <a:pPr>
+              <a:defRPr sz="1200" b="0" i="0" u="none" strike="noStrike">
+                <a:solidFill>
+                  <a:srgbClr val="4B5563"/>
+                </a:solidFill>
+                <a:latin typeface="Arial"/>
+              </a:defRPr>
+            </a:pPr>
+            <a:endParaRPr lang="en-US"/>
+          </a:p>
+        </c:txPr>
+        <c:crossAx val="2094734554"/>
+        <c:crosses val="autoZero"/>
+        <c:crossBetween val="between"/>
+      </c:valAx>
+      <c:spPr>
+        <a:noFill/>
+        <a:ln>
+          <a:noFill/>
+        </a:ln>
+        <a:effectLst/>
+      </c:spPr>
+    </c:plotArea>
+    <c:legend>
+      <c:legendPos val="t"/>
+      <c:overlay val="0"/>
+    </c:legend>
+    <c:plotVisOnly val="1"/>
+    <c:dispBlanksAs val="span"/>
+  </c:chart>
+  <c:spPr>
+    <a:noFill/>
+    <a:ln>
+      <a:noFill/>
+    </a:ln>
+    <a:effectLst/>
+  </c:spPr>
+  <c:externalData r:id="rId1">
+    <c:autoUpdate val="0"/>
+  </c:externalData>
+</c:chartSpace>
 </file>
 
 <file path=ppt/notesMasters/notesMaster1.xml><?xml version="1.0" encoding="utf-8"?>
@@ -900,6 +1230,270 @@
 </p:notes>
 </file>
 
+<file path=ppt/notesSlides/notesSlide6.xml><?xml version="1.0" encoding="utf-8"?>
+<p:notes xmlns:a="http://schemas.openxmlformats.org/drawingml/2006/main" xmlns:r="http://schemas.openxmlformats.org/officeDocument/2006/relationships" xmlns:p="http://schemas.openxmlformats.org/presentationml/2006/main">
+  <p:cSld>
+    <p:spTree>
+      <p:nvGrpSpPr>
+        <p:cNvPr id="1" name=""/>
+        <p:cNvGrpSpPr/>
+        <p:nvPr/>
+      </p:nvGrpSpPr>
+      <p:grpSpPr>
+        <a:xfrm>
+          <a:off x="0" y="0"/>
+          <a:ext cx="0" cy="0"/>
+          <a:chOff x="0" y="0"/>
+          <a:chExt cx="0" cy="0"/>
+        </a:xfrm>
+      </p:grpSpPr>
+      <p:sp>
+        <p:nvSpPr>
+          <p:cNvPr id="2" name="Slide Image Placeholder 1"/>
+          <p:cNvSpPr>
+            <a:spLocks noGrp="1" noRot="1" noChangeAspect="1"/>
+          </p:cNvSpPr>
+          <p:nvPr>
+            <p:ph type="sldImg"/>
+          </p:nvPr>
+        </p:nvSpPr>
+        <p:spPr/>
+      </p:sp>
+      <p:sp>
+        <p:nvSpPr>
+          <p:cNvPr id="3" name="Notes Placeholder 2"/>
+          <p:cNvSpPr>
+            <a:spLocks noGrp="1"/>
+          </p:cNvSpPr>
+          <p:nvPr>
+            <p:ph type="body" idx="1"/>
+          </p:nvPr>
+        </p:nvSpPr>
+        <p:spPr/>
+        <p:txBody>
+          <a:bodyPr/>
+          <a:lstStyle/>
+          <a:p>
+            <a:r>
+              <a:rPr lang="en-US" dirty="0"/>
+              <a:t/>
+            </a:r>
+            <a:endParaRPr lang="en-US" dirty="0"/>
+          </a:p>
+        </p:txBody>
+      </p:sp>
+      <p:sp>
+        <p:nvSpPr>
+          <p:cNvPr id="4" name="Slide Number Placeholder 3"/>
+          <p:cNvSpPr>
+            <a:spLocks noGrp="1"/>
+          </p:cNvSpPr>
+          <p:nvPr>
+            <p:ph type="sldNum" sz="quarter" idx="10"/>
+          </p:nvPr>
+        </p:nvSpPr>
+        <p:spPr/>
+        <p:txBody>
+          <a:bodyPr/>
+          <a:lstStyle/>
+          <a:p>
+            <a:fld id="{F7021451-1387-4CA6-816F-3879F97B5CBC}" type="slidenum">
+              <a:rPr lang="en-US"/>
+              <a:t>6</a:t>
+            </a:fld>
+            <a:endParaRPr lang="en-US"/>
+          </a:p>
+        </p:txBody>
+      </p:sp>
+    </p:spTree>
+    <p:extLst>
+      <p:ext uri="{BB962C8B-B14F-4D97-AF65-F5344CB8AC3E}">
+        <p14:creationId xmlns:p14="http://schemas.microsoft.com/office/powerpoint/2010/main" val="1024086991"/>
+      </p:ext>
+    </p:extLst>
+  </p:cSld>
+  <p:clrMapOvr>
+    <a:masterClrMapping/>
+  </p:clrMapOvr>
+</p:notes>
+</file>
+
+<file path=ppt/notesSlides/notesSlide7.xml><?xml version="1.0" encoding="utf-8"?>
+<p:notes xmlns:a="http://schemas.openxmlformats.org/drawingml/2006/main" xmlns:r="http://schemas.openxmlformats.org/officeDocument/2006/relationships" xmlns:p="http://schemas.openxmlformats.org/presentationml/2006/main">
+  <p:cSld>
+    <p:spTree>
+      <p:nvGrpSpPr>
+        <p:cNvPr id="1" name=""/>
+        <p:cNvGrpSpPr/>
+        <p:nvPr/>
+      </p:nvGrpSpPr>
+      <p:grpSpPr>
+        <a:xfrm>
+          <a:off x="0" y="0"/>
+          <a:ext cx="0" cy="0"/>
+          <a:chOff x="0" y="0"/>
+          <a:chExt cx="0" cy="0"/>
+        </a:xfrm>
+      </p:grpSpPr>
+      <p:sp>
+        <p:nvSpPr>
+          <p:cNvPr id="2" name="Slide Image Placeholder 1"/>
+          <p:cNvSpPr>
+            <a:spLocks noGrp="1" noRot="1" noChangeAspect="1"/>
+          </p:cNvSpPr>
+          <p:nvPr>
+            <p:ph type="sldImg"/>
+          </p:nvPr>
+        </p:nvSpPr>
+        <p:spPr/>
+      </p:sp>
+      <p:sp>
+        <p:nvSpPr>
+          <p:cNvPr id="3" name="Notes Placeholder 2"/>
+          <p:cNvSpPr>
+            <a:spLocks noGrp="1"/>
+          </p:cNvSpPr>
+          <p:nvPr>
+            <p:ph type="body" idx="1"/>
+          </p:nvPr>
+        </p:nvSpPr>
+        <p:spPr/>
+        <p:txBody>
+          <a:bodyPr/>
+          <a:lstStyle/>
+          <a:p>
+            <a:r>
+              <a:rPr lang="en-US" dirty="0"/>
+              <a:t/>
+            </a:r>
+            <a:endParaRPr lang="en-US" dirty="0"/>
+          </a:p>
+        </p:txBody>
+      </p:sp>
+      <p:sp>
+        <p:nvSpPr>
+          <p:cNvPr id="4" name="Slide Number Placeholder 3"/>
+          <p:cNvSpPr>
+            <a:spLocks noGrp="1"/>
+          </p:cNvSpPr>
+          <p:nvPr>
+            <p:ph type="sldNum" sz="quarter" idx="10"/>
+          </p:nvPr>
+        </p:nvSpPr>
+        <p:spPr/>
+        <p:txBody>
+          <a:bodyPr/>
+          <a:lstStyle/>
+          <a:p>
+            <a:fld id="{F7021451-1387-4CA6-816F-3879F97B5CBC}" type="slidenum">
+              <a:rPr lang="en-US"/>
+              <a:t>7</a:t>
+            </a:fld>
+            <a:endParaRPr lang="en-US"/>
+          </a:p>
+        </p:txBody>
+      </p:sp>
+    </p:spTree>
+    <p:extLst>
+      <p:ext uri="{BB962C8B-B14F-4D97-AF65-F5344CB8AC3E}">
+        <p14:creationId xmlns:p14="http://schemas.microsoft.com/office/powerpoint/2010/main" val="1024086991"/>
+      </p:ext>
+    </p:extLst>
+  </p:cSld>
+  <p:clrMapOvr>
+    <a:masterClrMapping/>
+  </p:clrMapOvr>
+</p:notes>
+</file>
+
+<file path=ppt/notesSlides/notesSlide8.xml><?xml version="1.0" encoding="utf-8"?>
+<p:notes xmlns:a="http://schemas.openxmlformats.org/drawingml/2006/main" xmlns:r="http://schemas.openxmlformats.org/officeDocument/2006/relationships" xmlns:p="http://schemas.openxmlformats.org/presentationml/2006/main">
+  <p:cSld>
+    <p:spTree>
+      <p:nvGrpSpPr>
+        <p:cNvPr id="1" name=""/>
+        <p:cNvGrpSpPr/>
+        <p:nvPr/>
+      </p:nvGrpSpPr>
+      <p:grpSpPr>
+        <a:xfrm>
+          <a:off x="0" y="0"/>
+          <a:ext cx="0" cy="0"/>
+          <a:chOff x="0" y="0"/>
+          <a:chExt cx="0" cy="0"/>
+        </a:xfrm>
+      </p:grpSpPr>
+      <p:sp>
+        <p:nvSpPr>
+          <p:cNvPr id="2" name="Slide Image Placeholder 1"/>
+          <p:cNvSpPr>
+            <a:spLocks noGrp="1" noRot="1" noChangeAspect="1"/>
+          </p:cNvSpPr>
+          <p:nvPr>
+            <p:ph type="sldImg"/>
+          </p:nvPr>
+        </p:nvSpPr>
+        <p:spPr/>
+      </p:sp>
+      <p:sp>
+        <p:nvSpPr>
+          <p:cNvPr id="3" name="Notes Placeholder 2"/>
+          <p:cNvSpPr>
+            <a:spLocks noGrp="1"/>
+          </p:cNvSpPr>
+          <p:nvPr>
+            <p:ph type="body" idx="1"/>
+          </p:nvPr>
+        </p:nvSpPr>
+        <p:spPr/>
+        <p:txBody>
+          <a:bodyPr/>
+          <a:lstStyle/>
+          <a:p>
+            <a:r>
+              <a:rPr lang="en-US" dirty="0"/>
+              <a:t/>
+            </a:r>
+            <a:endParaRPr lang="en-US" dirty="0"/>
+          </a:p>
+        </p:txBody>
+      </p:sp>
+      <p:sp>
+        <p:nvSpPr>
+          <p:cNvPr id="4" name="Slide Number Placeholder 3"/>
+          <p:cNvSpPr>
+            <a:spLocks noGrp="1"/>
+          </p:cNvSpPr>
+          <p:nvPr>
+            <p:ph type="sldNum" sz="quarter" idx="10"/>
+          </p:nvPr>
+        </p:nvSpPr>
+        <p:spPr/>
+        <p:txBody>
+          <a:bodyPr/>
+          <a:lstStyle/>
+          <a:p>
+            <a:fld id="{F7021451-1387-4CA6-816F-3879F97B5CBC}" type="slidenum">
+              <a:rPr lang="en-US"/>
+              <a:t>8</a:t>
+            </a:fld>
+            <a:endParaRPr lang="en-US"/>
+          </a:p>
+        </p:txBody>
+      </p:sp>
+    </p:spTree>
+    <p:extLst>
+      <p:ext uri="{BB962C8B-B14F-4D97-AF65-F5344CB8AC3E}">
+        <p14:creationId xmlns:p14="http://schemas.microsoft.com/office/powerpoint/2010/main" val="1024086991"/>
+      </p:ext>
+    </p:extLst>
+  </p:cSld>
+  <p:clrMapOvr>
+    <a:masterClrMapping/>
+  </p:clrMapOvr>
+</p:notes>
+</file>
+
 <file path=ppt/slideLayouts/slideLayout1.xml><?xml version="1.0" encoding="utf-8"?>
 <p:sldLayout xmlns:a="http://schemas.openxmlformats.org/drawingml/2006/main" xmlns:r="http://schemas.openxmlformats.org/officeDocument/2006/relationships" xmlns:p="http://schemas.openxmlformats.org/presentationml/2006/main" preserve="1">
   <p:cSld name="DEFAULT">
@@ -1900,8 +2494,8 @@
         </p:nvSpPr>
         <p:spPr>
           <a:xfrm>
-            <a:off x="731520" y="1463040"/>
-            <a:ext cx="5120640" cy="1965960"/>
+            <a:off x="365760" y="1463040"/>
+            <a:ext cx="5486400" cy="2240280"/>
           </a:xfrm>
           <a:prstGeom prst="roundRect">
             <a:avLst/>
@@ -1925,8 +2519,8 @@
         </p:nvSpPr>
         <p:spPr>
           <a:xfrm>
-            <a:off x="731520" y="1463040"/>
-            <a:ext cx="5120640" cy="73152"/>
+            <a:off x="365760" y="1463040"/>
+            <a:ext cx="5486400" cy="73152"/>
           </a:xfrm>
           <a:prstGeom prst="rect">
             <a:avLst/>
@@ -1945,8 +2539,8 @@
         </p:nvSpPr>
         <p:spPr>
           <a:xfrm>
-            <a:off x="822960" y="1755648"/>
-            <a:ext cx="914400" cy="1371600"/>
+            <a:off x="502920" y="1737360"/>
+            <a:ext cx="1188720" cy="1691640"/>
           </a:xfrm>
           <a:prstGeom prst="rect">
             <a:avLst/>
@@ -1962,14 +2556,14 @@
               <a:buNone/>
             </a:pPr>
             <a:r>
-              <a:rPr lang="en-US" sz="2800" dirty="0">
+              <a:rPr lang="en-US" sz="4400" dirty="0">
                 <a:solidFill>
                   <a:srgbClr val="000000"/>
                 </a:solidFill>
               </a:rPr>
               <a:t>💡</a:t>
             </a:r>
-            <a:endParaRPr lang="en-US" sz="2800" dirty="0"/>
+            <a:endParaRPr lang="en-US" sz="4400" dirty="0"/>
           </a:p>
         </p:txBody>
       </p:sp>
@@ -1982,7 +2576,7 @@
         <p:spPr>
           <a:xfrm>
             <a:off x="1828800" y="1691640"/>
-            <a:ext cx="3931920" cy="320040"/>
+            <a:ext cx="3840480" cy="320040"/>
           </a:xfrm>
           <a:prstGeom prst="rect">
             <a:avLst/>
@@ -2014,14 +2608,37 @@
       </p:sp>
       <p:sp>
         <p:nvSpPr>
-          <p:cNvPr id="13" name="Text 11"/>
+          <p:cNvPr id="13" name="Shape 11"/>
           <p:cNvSpPr/>
           <p:nvPr/>
         </p:nvSpPr>
         <p:spPr>
           <a:xfrm>
             <a:off x="1828800" y="2057400"/>
-            <a:ext cx="3931920" cy="1280160"/>
+            <a:ext cx="3749040" cy="0"/>
+          </a:xfrm>
+          <a:prstGeom prst="line">
+            <a:avLst/>
+          </a:prstGeom>
+          <a:noFill/>
+          <a:ln w="12700">
+            <a:solidFill>
+              <a:srgbClr val="E9D5FF"/>
+            </a:solidFill>
+            <a:prstDash val="solid"/>
+          </a:ln>
+        </p:spPr>
+      </p:sp>
+      <p:sp>
+        <p:nvSpPr>
+          <p:cNvPr id="14" name="Text 12"/>
+          <p:cNvSpPr/>
+          <p:nvPr/>
+        </p:nvSpPr>
+        <p:spPr>
+          <a:xfrm>
+            <a:off x="1828800" y="2148840"/>
+            <a:ext cx="3840480" cy="1417320"/>
           </a:xfrm>
           <a:prstGeom prst="rect">
             <a:avLst/>
@@ -2040,7 +2657,7 @@
               <a:buNone/>
             </a:pPr>
             <a:r>
-              <a:rPr lang="en-US" sz="1000" dirty="0">
+              <a:rPr lang="en-US" sz="950" dirty="0">
                 <a:solidFill>
                   <a:srgbClr val="4B5563"/>
                 </a:solidFill>
@@ -2050,20 +2667,20 @@
               </a:rPr>
               <a:t>Bringing digital intelligence into physical robots to act, learn, and manipulate objects.</a:t>
             </a:r>
-            <a:endParaRPr lang="en-US" sz="1000" dirty="0"/>
-          </a:p>
-        </p:txBody>
-      </p:sp>
-      <p:sp>
-        <p:nvSpPr>
-          <p:cNvPr id="14" name="Shape 12"/>
-          <p:cNvSpPr/>
-          <p:nvPr/>
-        </p:nvSpPr>
-        <p:spPr>
-          <a:xfrm>
-            <a:off x="6309360" y="1463040"/>
-            <a:ext cx="5120640" cy="1965960"/>
+            <a:endParaRPr lang="en-US" sz="950" dirty="0"/>
+          </a:p>
+        </p:txBody>
+      </p:sp>
+      <p:sp>
+        <p:nvSpPr>
+          <p:cNvPr id="15" name="Shape 13"/>
+          <p:cNvSpPr/>
+          <p:nvPr/>
+        </p:nvSpPr>
+        <p:spPr>
+          <a:xfrm>
+            <a:off x="6336792" y="1463040"/>
+            <a:ext cx="5486400" cy="2240280"/>
           </a:xfrm>
           <a:prstGeom prst="roundRect">
             <a:avLst/>
@@ -2081,14 +2698,14 @@
       </p:sp>
       <p:sp>
         <p:nvSpPr>
-          <p:cNvPr id="15" name="Shape 13"/>
-          <p:cNvSpPr/>
-          <p:nvPr/>
-        </p:nvSpPr>
-        <p:spPr>
-          <a:xfrm>
-            <a:off x="6309360" y="1463040"/>
-            <a:ext cx="5120640" cy="73152"/>
+          <p:cNvPr id="16" name="Shape 14"/>
+          <p:cNvSpPr/>
+          <p:nvPr/>
+        </p:nvSpPr>
+        <p:spPr>
+          <a:xfrm>
+            <a:off x="6336792" y="1463040"/>
+            <a:ext cx="5486400" cy="73152"/>
           </a:xfrm>
           <a:prstGeom prst="rect">
             <a:avLst/>
@@ -2101,14 +2718,14 @@
       </p:sp>
       <p:sp>
         <p:nvSpPr>
-          <p:cNvPr id="16" name="Text 14"/>
-          <p:cNvSpPr/>
-          <p:nvPr/>
-        </p:nvSpPr>
-        <p:spPr>
-          <a:xfrm>
-            <a:off x="6400800" y="1755648"/>
-            <a:ext cx="914400" cy="1371600"/>
+          <p:cNvPr id="17" name="Text 15"/>
+          <p:cNvSpPr/>
+          <p:nvPr/>
+        </p:nvSpPr>
+        <p:spPr>
+          <a:xfrm>
+            <a:off x="6473952" y="1737360"/>
+            <a:ext cx="1188720" cy="1691640"/>
           </a:xfrm>
           <a:prstGeom prst="rect">
             <a:avLst/>
@@ -2124,27 +2741,27 @@
               <a:buNone/>
             </a:pPr>
             <a:r>
-              <a:rPr lang="en-US" sz="2800" dirty="0">
+              <a:rPr lang="en-US" sz="4400" dirty="0">
                 <a:solidFill>
                   <a:srgbClr val="000000"/>
                 </a:solidFill>
               </a:rPr>
               <a:t>🔹</a:t>
             </a:r>
-            <a:endParaRPr lang="en-US" sz="2800" dirty="0"/>
-          </a:p>
-        </p:txBody>
-      </p:sp>
-      <p:sp>
-        <p:nvSpPr>
-          <p:cNvPr id="17" name="Text 15"/>
-          <p:cNvSpPr/>
-          <p:nvPr/>
-        </p:nvSpPr>
-        <p:spPr>
-          <a:xfrm>
-            <a:off x="7406640" y="1691640"/>
-            <a:ext cx="3931920" cy="320040"/>
+            <a:endParaRPr lang="en-US" sz="4400" dirty="0"/>
+          </a:p>
+        </p:txBody>
+      </p:sp>
+      <p:sp>
+        <p:nvSpPr>
+          <p:cNvPr id="18" name="Text 16"/>
+          <p:cNvSpPr/>
+          <p:nvPr/>
+        </p:nvSpPr>
+        <p:spPr>
+          <a:xfrm>
+            <a:off x="7799832" y="1691640"/>
+            <a:ext cx="3840480" cy="320040"/>
           </a:xfrm>
           <a:prstGeom prst="rect">
             <a:avLst/>
@@ -2176,14 +2793,37 @@
       </p:sp>
       <p:sp>
         <p:nvSpPr>
-          <p:cNvPr id="18" name="Text 16"/>
-          <p:cNvSpPr/>
-          <p:nvPr/>
-        </p:nvSpPr>
-        <p:spPr>
-          <a:xfrm>
-            <a:off x="7406640" y="2057400"/>
-            <a:ext cx="3931920" cy="1280160"/>
+          <p:cNvPr id="19" name="Shape 17"/>
+          <p:cNvSpPr/>
+          <p:nvPr/>
+        </p:nvSpPr>
+        <p:spPr>
+          <a:xfrm>
+            <a:off x="7799832" y="2057400"/>
+            <a:ext cx="3749040" cy="0"/>
+          </a:xfrm>
+          <a:prstGeom prst="line">
+            <a:avLst/>
+          </a:prstGeom>
+          <a:noFill/>
+          <a:ln w="12700">
+            <a:solidFill>
+              <a:srgbClr val="E9D5FF"/>
+            </a:solidFill>
+            <a:prstDash val="solid"/>
+          </a:ln>
+        </p:spPr>
+      </p:sp>
+      <p:sp>
+        <p:nvSpPr>
+          <p:cNvPr id="20" name="Text 18"/>
+          <p:cNvSpPr/>
+          <p:nvPr/>
+        </p:nvSpPr>
+        <p:spPr>
+          <a:xfrm>
+            <a:off x="7799832" y="2148840"/>
+            <a:ext cx="3840480" cy="1417320"/>
           </a:xfrm>
           <a:prstGeom prst="rect">
             <a:avLst/>
@@ -2202,7 +2842,7 @@
               <a:buNone/>
             </a:pPr>
             <a:r>
-              <a:rPr lang="en-US" sz="1000" dirty="0">
+              <a:rPr lang="en-US" sz="950" dirty="0">
                 <a:solidFill>
                   <a:srgbClr val="4B5563"/>
                 </a:solidFill>
@@ -2212,20 +2852,20 @@
               </a:rPr>
               <a:t>Voxel-level 3D semantic mapping, real-time depth tracing, and active sensor fusion.</a:t>
             </a:r>
-            <a:endParaRPr lang="en-US" sz="1000" dirty="0"/>
-          </a:p>
-        </p:txBody>
-      </p:sp>
-      <p:sp>
-        <p:nvSpPr>
-          <p:cNvPr id="19" name="Shape 17"/>
-          <p:cNvSpPr/>
-          <p:nvPr/>
-        </p:nvSpPr>
-        <p:spPr>
-          <a:xfrm>
-            <a:off x="731520" y="3886200"/>
-            <a:ext cx="5120640" cy="1965960"/>
+            <a:endParaRPr lang="en-US" sz="950" dirty="0"/>
+          </a:p>
+        </p:txBody>
+      </p:sp>
+      <p:sp>
+        <p:nvSpPr>
+          <p:cNvPr id="21" name="Shape 19"/>
+          <p:cNvSpPr/>
+          <p:nvPr/>
+        </p:nvSpPr>
+        <p:spPr>
+          <a:xfrm>
+            <a:off x="365760" y="4023360"/>
+            <a:ext cx="5486400" cy="2240280"/>
           </a:xfrm>
           <a:prstGeom prst="roundRect">
             <a:avLst/>
@@ -2243,14 +2883,14 @@
       </p:sp>
       <p:sp>
         <p:nvSpPr>
-          <p:cNvPr id="20" name="Shape 18"/>
-          <p:cNvSpPr/>
-          <p:nvPr/>
-        </p:nvSpPr>
-        <p:spPr>
-          <a:xfrm>
-            <a:off x="731520" y="3886200"/>
-            <a:ext cx="5120640" cy="73152"/>
+          <p:cNvPr id="22" name="Shape 20"/>
+          <p:cNvSpPr/>
+          <p:nvPr/>
+        </p:nvSpPr>
+        <p:spPr>
+          <a:xfrm>
+            <a:off x="365760" y="4023360"/>
+            <a:ext cx="5486400" cy="73152"/>
           </a:xfrm>
           <a:prstGeom prst="rect">
             <a:avLst/>
@@ -2263,14 +2903,14 @@
       </p:sp>
       <p:sp>
         <p:nvSpPr>
-          <p:cNvPr id="21" name="Text 19"/>
-          <p:cNvSpPr/>
-          <p:nvPr/>
-        </p:nvSpPr>
-        <p:spPr>
-          <a:xfrm>
-            <a:off x="822960" y="4178808"/>
-            <a:ext cx="914400" cy="1371600"/>
+          <p:cNvPr id="23" name="Text 21"/>
+          <p:cNvSpPr/>
+          <p:nvPr/>
+        </p:nvSpPr>
+        <p:spPr>
+          <a:xfrm>
+            <a:off x="502920" y="4297680"/>
+            <a:ext cx="1188720" cy="1691640"/>
           </a:xfrm>
           <a:prstGeom prst="rect">
             <a:avLst/>
@@ -2286,27 +2926,27 @@
               <a:buNone/>
             </a:pPr>
             <a:r>
-              <a:rPr lang="en-US" sz="2800" dirty="0">
+              <a:rPr lang="en-US" sz="4400" dirty="0">
                 <a:solidFill>
                   <a:srgbClr val="000000"/>
                 </a:solidFill>
               </a:rPr>
               <a:t>🔹</a:t>
             </a:r>
-            <a:endParaRPr lang="en-US" sz="2800" dirty="0"/>
-          </a:p>
-        </p:txBody>
-      </p:sp>
-      <p:sp>
-        <p:nvSpPr>
-          <p:cNvPr id="22" name="Text 20"/>
-          <p:cNvSpPr/>
-          <p:nvPr/>
-        </p:nvSpPr>
-        <p:spPr>
-          <a:xfrm>
-            <a:off x="1828800" y="4114800"/>
-            <a:ext cx="3931920" cy="320040"/>
+            <a:endParaRPr lang="en-US" sz="4400" dirty="0"/>
+          </a:p>
+        </p:txBody>
+      </p:sp>
+      <p:sp>
+        <p:nvSpPr>
+          <p:cNvPr id="24" name="Text 22"/>
+          <p:cNvSpPr/>
+          <p:nvPr/>
+        </p:nvSpPr>
+        <p:spPr>
+          <a:xfrm>
+            <a:off x="1828800" y="4251960"/>
+            <a:ext cx="3840480" cy="320040"/>
           </a:xfrm>
           <a:prstGeom prst="rect">
             <a:avLst/>
@@ -2338,14 +2978,37 @@
       </p:sp>
       <p:sp>
         <p:nvSpPr>
-          <p:cNvPr id="23" name="Text 21"/>
-          <p:cNvSpPr/>
-          <p:nvPr/>
-        </p:nvSpPr>
-        <p:spPr>
-          <a:xfrm>
-            <a:off x="1828800" y="4480560"/>
-            <a:ext cx="3931920" cy="1280160"/>
+          <p:cNvPr id="25" name="Shape 23"/>
+          <p:cNvSpPr/>
+          <p:nvPr/>
+        </p:nvSpPr>
+        <p:spPr>
+          <a:xfrm>
+            <a:off x="1828800" y="4617720"/>
+            <a:ext cx="3749040" cy="0"/>
+          </a:xfrm>
+          <a:prstGeom prst="line">
+            <a:avLst/>
+          </a:prstGeom>
+          <a:noFill/>
+          <a:ln w="12700">
+            <a:solidFill>
+              <a:srgbClr val="E9D5FF"/>
+            </a:solidFill>
+            <a:prstDash val="solid"/>
+          </a:ln>
+        </p:spPr>
+      </p:sp>
+      <p:sp>
+        <p:nvSpPr>
+          <p:cNvPr id="26" name="Text 24"/>
+          <p:cNvSpPr/>
+          <p:nvPr/>
+        </p:nvSpPr>
+        <p:spPr>
+          <a:xfrm>
+            <a:off x="1828800" y="4709160"/>
+            <a:ext cx="3840480" cy="1417320"/>
           </a:xfrm>
           <a:prstGeom prst="rect">
             <a:avLst/>
@@ -2364,7 +3027,7 @@
               <a:buNone/>
             </a:pPr>
             <a:r>
-              <a:rPr lang="en-US" sz="1000" dirty="0">
+              <a:rPr lang="en-US" sz="950" dirty="0">
                 <a:solidFill>
                   <a:srgbClr val="4B5563"/>
                 </a:solidFill>
@@ -2374,20 +3037,20 @@
               </a:rPr>
               <a:t>Reactive trajectory optimization, localized SLAM, and dynamic obstacle avoidance.</a:t>
             </a:r>
-            <a:endParaRPr lang="en-US" sz="1000" dirty="0"/>
-          </a:p>
-        </p:txBody>
-      </p:sp>
-      <p:sp>
-        <p:nvSpPr>
-          <p:cNvPr id="24" name="Shape 22"/>
-          <p:cNvSpPr/>
-          <p:nvPr/>
-        </p:nvSpPr>
-        <p:spPr>
-          <a:xfrm>
-            <a:off x="6309360" y="3886200"/>
-            <a:ext cx="5120640" cy="1965960"/>
+            <a:endParaRPr lang="en-US" sz="950" dirty="0"/>
+          </a:p>
+        </p:txBody>
+      </p:sp>
+      <p:sp>
+        <p:nvSpPr>
+          <p:cNvPr id="27" name="Shape 25"/>
+          <p:cNvSpPr/>
+          <p:nvPr/>
+        </p:nvSpPr>
+        <p:spPr>
+          <a:xfrm>
+            <a:off x="6336792" y="4023360"/>
+            <a:ext cx="5486400" cy="2240280"/>
           </a:xfrm>
           <a:prstGeom prst="roundRect">
             <a:avLst/>
@@ -2405,14 +3068,14 @@
       </p:sp>
       <p:sp>
         <p:nvSpPr>
-          <p:cNvPr id="25" name="Shape 23"/>
-          <p:cNvSpPr/>
-          <p:nvPr/>
-        </p:nvSpPr>
-        <p:spPr>
-          <a:xfrm>
-            <a:off x="6309360" y="3886200"/>
-            <a:ext cx="5120640" cy="73152"/>
+          <p:cNvPr id="28" name="Shape 26"/>
+          <p:cNvSpPr/>
+          <p:nvPr/>
+        </p:nvSpPr>
+        <p:spPr>
+          <a:xfrm>
+            <a:off x="6336792" y="4023360"/>
+            <a:ext cx="5486400" cy="73152"/>
           </a:xfrm>
           <a:prstGeom prst="rect">
             <a:avLst/>
@@ -2425,14 +3088,14 @@
       </p:sp>
       <p:sp>
         <p:nvSpPr>
-          <p:cNvPr id="26" name="Text 24"/>
-          <p:cNvSpPr/>
-          <p:nvPr/>
-        </p:nvSpPr>
-        <p:spPr>
-          <a:xfrm>
-            <a:off x="6400800" y="4178808"/>
-            <a:ext cx="914400" cy="1371600"/>
+          <p:cNvPr id="29" name="Text 27"/>
+          <p:cNvSpPr/>
+          <p:nvPr/>
+        </p:nvSpPr>
+        <p:spPr>
+          <a:xfrm>
+            <a:off x="6473952" y="4297680"/>
+            <a:ext cx="1188720" cy="1691640"/>
           </a:xfrm>
           <a:prstGeom prst="rect">
             <a:avLst/>
@@ -2448,27 +3111,27 @@
               <a:buNone/>
             </a:pPr>
             <a:r>
-              <a:rPr lang="en-US" sz="2800" dirty="0">
+              <a:rPr lang="en-US" sz="4400" dirty="0">
                 <a:solidFill>
                   <a:srgbClr val="000000"/>
                 </a:solidFill>
               </a:rPr>
               <a:t>🔹</a:t>
             </a:r>
-            <a:endParaRPr lang="en-US" sz="2800" dirty="0"/>
-          </a:p>
-        </p:txBody>
-      </p:sp>
-      <p:sp>
-        <p:nvSpPr>
-          <p:cNvPr id="27" name="Text 25"/>
-          <p:cNvSpPr/>
-          <p:nvPr/>
-        </p:nvSpPr>
-        <p:spPr>
-          <a:xfrm>
-            <a:off x="7406640" y="4114800"/>
-            <a:ext cx="3931920" cy="320040"/>
+            <a:endParaRPr lang="en-US" sz="4400" dirty="0"/>
+          </a:p>
+        </p:txBody>
+      </p:sp>
+      <p:sp>
+        <p:nvSpPr>
+          <p:cNvPr id="30" name="Text 28"/>
+          <p:cNvSpPr/>
+          <p:nvPr/>
+        </p:nvSpPr>
+        <p:spPr>
+          <a:xfrm>
+            <a:off x="7799832" y="4251960"/>
+            <a:ext cx="3840480" cy="320040"/>
           </a:xfrm>
           <a:prstGeom prst="rect">
             <a:avLst/>
@@ -2500,14 +3163,37 @@
       </p:sp>
       <p:sp>
         <p:nvSpPr>
-          <p:cNvPr id="28" name="Text 26"/>
-          <p:cNvSpPr/>
-          <p:nvPr/>
-        </p:nvSpPr>
-        <p:spPr>
-          <a:xfrm>
-            <a:off x="7406640" y="4480560"/>
-            <a:ext cx="3931920" cy="1280160"/>
+          <p:cNvPr id="31" name="Shape 29"/>
+          <p:cNvSpPr/>
+          <p:nvPr/>
+        </p:nvSpPr>
+        <p:spPr>
+          <a:xfrm>
+            <a:off x="7799832" y="4617720"/>
+            <a:ext cx="3749040" cy="0"/>
+          </a:xfrm>
+          <a:prstGeom prst="line">
+            <a:avLst/>
+          </a:prstGeom>
+          <a:noFill/>
+          <a:ln w="12700">
+            <a:solidFill>
+              <a:srgbClr val="E9D5FF"/>
+            </a:solidFill>
+            <a:prstDash val="solid"/>
+          </a:ln>
+        </p:spPr>
+      </p:sp>
+      <p:sp>
+        <p:nvSpPr>
+          <p:cNvPr id="32" name="Text 30"/>
+          <p:cNvSpPr/>
+          <p:nvPr/>
+        </p:nvSpPr>
+        <p:spPr>
+          <a:xfrm>
+            <a:off x="7799832" y="4709160"/>
+            <a:ext cx="3840480" cy="1417320"/>
           </a:xfrm>
           <a:prstGeom prst="rect">
             <a:avLst/>
@@ -2526,7 +3212,7 @@
               <a:buNone/>
             </a:pPr>
             <a:r>
-              <a:rPr lang="en-US" sz="1000" dirty="0">
+              <a:rPr lang="en-US" sz="950" dirty="0">
                 <a:solidFill>
                   <a:srgbClr val="4B5563"/>
                 </a:solidFill>
@@ -2536,7 +3222,7 @@
               </a:rPr>
               <a:t>Deploying agents to automated assembly lines, warehouses, and complex physical environments.</a:t>
             </a:r>
-            <a:endParaRPr lang="en-US" sz="1000" dirty="0"/>
+            <a:endParaRPr lang="en-US" sz="950" dirty="0"/>
           </a:p>
         </p:txBody>
       </p:sp>
@@ -3767,7 +4453,7 @@
       </p:sp>
       <p:pic>
         <p:nvPicPr>
-          <p:cNvPr id="13" name="Image 0" descr="/mnt/c/Users/Administrator/.gemini/skills/markdown-to-pptx/assets/model_architecture.jpg">    </p:cNvPr>
+          <p:cNvPr id="13" name="Image 0" descr="/mnt/c/Users/Administrator/.gemini/skills/markdown-to-pptx/tests/assets/model_architecture.jpg">    </p:cNvPr>
           <p:cNvPicPr>
             <a:picLocks noChangeAspect="1"/>
           </p:cNvPicPr>
@@ -3789,6 +4475,1363 @@
           </a:prstGeom>
         </p:spPr>
       </p:pic>
+    </p:spTree>
+  </p:cSld>
+  <p:clrMapOvr>
+    <a:masterClrMapping/>
+  </p:clrMapOvr>
+</p:sld>
+</file>
+
+<file path=ppt/slides/slide6.xml><?xml version="1.0" encoding="utf-8"?>
+<p:sld xmlns:a="http://schemas.openxmlformats.org/drawingml/2006/main" xmlns:r="http://schemas.openxmlformats.org/officeDocument/2006/relationships" xmlns:p="http://schemas.openxmlformats.org/presentationml/2006/main">
+  <p:cSld name="Slide 6">
+    <p:bg>
+      <p:bgPr>
+        <a:solidFill>
+          <a:srgbClr val="FAF5FF"/>
+        </a:solidFill>
+      </p:bgPr>
+    </p:bg>
+    <p:spTree>
+      <p:nvGrpSpPr>
+        <p:cNvPr id="1" name=""/>
+        <p:cNvGrpSpPr/>
+        <p:nvPr/>
+      </p:nvGrpSpPr>
+      <p:grpSpPr>
+        <a:xfrm>
+          <a:off x="0" y="0"/>
+          <a:ext cx="0" cy="0"/>
+          <a:chOff x="0" y="0"/>
+          <a:chExt cx="0" cy="0"/>
+        </a:xfrm>
+      </p:grpSpPr>
+      <p:sp>
+        <p:nvSpPr>
+          <p:cNvPr id="2" name="Text 0"/>
+          <p:cNvSpPr/>
+          <p:nvPr/>
+        </p:nvSpPr>
+        <p:spPr>
+          <a:xfrm>
+            <a:off x="731520" y="137160"/>
+            <a:ext cx="5486400" cy="228600"/>
+          </a:xfrm>
+          <a:prstGeom prst="rect">
+            <a:avLst/>
+          </a:prstGeom>
+          <a:noFill/>
+          <a:ln/>
+        </p:spPr>
+        <p:txBody>
+          <a:bodyPr wrap="square" lIns="0" tIns="0" rIns="0" bIns="0" rtlCol="0" anchor="ctr"/>
+          <a:lstStyle/>
+          <a:p>
+            <a:pPr algn="l" indent="0" marL="0">
+              <a:buNone/>
+            </a:pPr>
+            <a:r>
+              <a:rPr lang="en-US" sz="900" b="1" dirty="0">
+                <a:solidFill>
+                  <a:srgbClr val="4B5563"/>
+                </a:solidFill>
+                <a:latin typeface="Trebuchet MS" pitchFamily="34" charset="0"/>
+                <a:ea typeface="Trebuchet MS" pitchFamily="34" charset="-122"/>
+                <a:cs typeface="Trebuchet MS" pitchFamily="34" charset="-120"/>
+              </a:rPr>
+              <a:t>SLIDE 05 | EMBODIED &amp; SPATIAL AI</a:t>
+            </a:r>
+            <a:endParaRPr lang="en-US" sz="900" dirty="0"/>
+          </a:p>
+        </p:txBody>
+      </p:sp>
+      <p:sp>
+        <p:nvSpPr>
+          <p:cNvPr id="3" name="Shape 1"/>
+          <p:cNvSpPr/>
+          <p:nvPr/>
+        </p:nvSpPr>
+        <p:spPr>
+          <a:xfrm>
+            <a:off x="11064240" y="210312"/>
+            <a:ext cx="73152" cy="73152"/>
+          </a:xfrm>
+          <a:prstGeom prst="oval">
+            <a:avLst/>
+          </a:prstGeom>
+          <a:solidFill>
+            <a:srgbClr val="FF5F56"/>
+          </a:solidFill>
+          <a:ln/>
+        </p:spPr>
+      </p:sp>
+      <p:sp>
+        <p:nvSpPr>
+          <p:cNvPr id="4" name="Shape 2"/>
+          <p:cNvSpPr/>
+          <p:nvPr/>
+        </p:nvSpPr>
+        <p:spPr>
+          <a:xfrm>
+            <a:off x="11173968" y="210312"/>
+            <a:ext cx="73152" cy="73152"/>
+          </a:xfrm>
+          <a:prstGeom prst="oval">
+            <a:avLst/>
+          </a:prstGeom>
+          <a:solidFill>
+            <a:srgbClr val="FFBD2E"/>
+          </a:solidFill>
+          <a:ln/>
+        </p:spPr>
+      </p:sp>
+      <p:sp>
+        <p:nvSpPr>
+          <p:cNvPr id="5" name="Shape 3"/>
+          <p:cNvSpPr/>
+          <p:nvPr/>
+        </p:nvSpPr>
+        <p:spPr>
+          <a:xfrm>
+            <a:off x="11283696" y="210312"/>
+            <a:ext cx="73152" cy="73152"/>
+          </a:xfrm>
+          <a:prstGeom prst="oval">
+            <a:avLst/>
+          </a:prstGeom>
+          <a:solidFill>
+            <a:srgbClr val="27C93F"/>
+          </a:solidFill>
+          <a:ln/>
+        </p:spPr>
+      </p:sp>
+      <p:sp>
+        <p:nvSpPr>
+          <p:cNvPr id="6" name="Shape 4"/>
+          <p:cNvSpPr/>
+          <p:nvPr/>
+        </p:nvSpPr>
+        <p:spPr>
+          <a:xfrm>
+            <a:off x="731520" y="502920"/>
+            <a:ext cx="109728" cy="457200"/>
+          </a:xfrm>
+          <a:prstGeom prst="rect">
+            <a:avLst/>
+          </a:prstGeom>
+          <a:solidFill>
+            <a:srgbClr val="D946EF"/>
+          </a:solidFill>
+          <a:ln/>
+        </p:spPr>
+      </p:sp>
+      <p:sp>
+        <p:nvSpPr>
+          <p:cNvPr id="7" name="Text 5"/>
+          <p:cNvSpPr/>
+          <p:nvPr/>
+        </p:nvSpPr>
+        <p:spPr>
+          <a:xfrm>
+            <a:off x="960120" y="365760"/>
+            <a:ext cx="10469880" cy="731520"/>
+          </a:xfrm>
+          <a:prstGeom prst="rect">
+            <a:avLst/>
+          </a:prstGeom>
+          <a:noFill/>
+          <a:ln/>
+        </p:spPr>
+        <p:txBody>
+          <a:bodyPr wrap="square" lIns="0" tIns="0" rIns="0" bIns="0" rtlCol="0" anchor="ctr"/>
+          <a:lstStyle/>
+          <a:p>
+            <a:pPr indent="0" marL="0">
+              <a:buNone/>
+            </a:pPr>
+            <a:r>
+              <a:rPr lang="en-US" sz="2800" b="1" dirty="0">
+                <a:solidFill>
+                  <a:srgbClr val="7C3AED"/>
+                </a:solidFill>
+                <a:latin typeface="Trebuchet MS" pitchFamily="34" charset="0"/>
+                <a:ea typeface="Trebuchet MS" pitchFamily="34" charset="-122"/>
+                <a:cs typeface="Trebuchet MS" pitchFamily="34" charset="-120"/>
+              </a:rPr>
+              <a:t>Performance Statistics</a:t>
+            </a:r>
+            <a:endParaRPr lang="en-US" sz="2800" dirty="0"/>
+          </a:p>
+        </p:txBody>
+      </p:sp>
+      <p:sp>
+        <p:nvSpPr>
+          <p:cNvPr id="8" name="Shape 6"/>
+          <p:cNvSpPr/>
+          <p:nvPr/>
+        </p:nvSpPr>
+        <p:spPr>
+          <a:xfrm>
+            <a:off x="731520" y="1143000"/>
+            <a:ext cx="10698480" cy="0"/>
+          </a:xfrm>
+          <a:prstGeom prst="line">
+            <a:avLst/>
+          </a:prstGeom>
+          <a:noFill/>
+          <a:ln w="19050">
+            <a:solidFill>
+              <a:srgbClr val="E9D5FF"/>
+            </a:solidFill>
+            <a:prstDash val="solid"/>
+          </a:ln>
+        </p:spPr>
+      </p:sp>
+      <p:sp>
+        <p:nvSpPr>
+          <p:cNvPr id="9" name="Shape 7"/>
+          <p:cNvSpPr/>
+          <p:nvPr/>
+        </p:nvSpPr>
+        <p:spPr>
+          <a:xfrm>
+            <a:off x="731520" y="1463040"/>
+            <a:ext cx="3322320" cy="4389120"/>
+          </a:xfrm>
+          <a:prstGeom prst="roundRect">
+            <a:avLst/>
+          </a:prstGeom>
+          <a:solidFill>
+            <a:srgbClr val="FFFFFF"/>
+          </a:solidFill>
+          <a:ln w="19050">
+            <a:solidFill>
+              <a:srgbClr val="E9D5FF"/>
+            </a:solidFill>
+            <a:prstDash val="solid"/>
+          </a:ln>
+        </p:spPr>
+      </p:sp>
+      <p:sp>
+        <p:nvSpPr>
+          <p:cNvPr id="10" name="Shape 8"/>
+          <p:cNvSpPr/>
+          <p:nvPr/>
+        </p:nvSpPr>
+        <p:spPr>
+          <a:xfrm>
+            <a:off x="731520" y="1463040"/>
+            <a:ext cx="3322320" cy="73152"/>
+          </a:xfrm>
+          <a:prstGeom prst="rect">
+            <a:avLst/>
+          </a:prstGeom>
+          <a:solidFill>
+            <a:srgbClr val="D946EF"/>
+          </a:solidFill>
+          <a:ln/>
+        </p:spPr>
+      </p:sp>
+      <p:sp>
+        <p:nvSpPr>
+          <p:cNvPr id="11" name="Text 9"/>
+          <p:cNvSpPr/>
+          <p:nvPr/>
+        </p:nvSpPr>
+        <p:spPr>
+          <a:xfrm>
+            <a:off x="822960" y="1783080"/>
+            <a:ext cx="3139440" cy="822960"/>
+          </a:xfrm>
+          <a:prstGeom prst="rect">
+            <a:avLst/>
+          </a:prstGeom>
+          <a:noFill/>
+          <a:ln/>
+        </p:spPr>
+        <p:txBody>
+          <a:bodyPr wrap="square" lIns="0" tIns="0" rIns="0" bIns="0" rtlCol="0" anchor="ctr"/>
+          <a:lstStyle/>
+          <a:p>
+            <a:pPr algn="ctr" indent="0" marL="0">
+              <a:buNone/>
+            </a:pPr>
+            <a:r>
+              <a:rPr lang="en-US" sz="3800" b="1" dirty="0">
+                <a:solidFill>
+                  <a:srgbClr val="D946EF"/>
+                </a:solidFill>
+                <a:latin typeface="Georgia, 'Microsoft YaHei', serif" pitchFamily="34" charset="0"/>
+                <a:ea typeface="Georgia, 'Microsoft YaHei', serif" pitchFamily="34" charset="-122"/>
+                <a:cs typeface="Georgia, 'Microsoft YaHei', serif" pitchFamily="34" charset="-120"/>
+              </a:rPr>
+              <a:t>98.2%</a:t>
+            </a:r>
+            <a:endParaRPr lang="en-US" sz="3800" dirty="0"/>
+          </a:p>
+        </p:txBody>
+      </p:sp>
+      <p:sp>
+        <p:nvSpPr>
+          <p:cNvPr id="12" name="Text 10"/>
+          <p:cNvSpPr/>
+          <p:nvPr/>
+        </p:nvSpPr>
+        <p:spPr>
+          <a:xfrm>
+            <a:off x="914400" y="2697480"/>
+            <a:ext cx="2956560" cy="3017520"/>
+          </a:xfrm>
+          <a:prstGeom prst="rect">
+            <a:avLst/>
+          </a:prstGeom>
+          <a:noFill/>
+          <a:ln/>
+        </p:spPr>
+        <p:txBody>
+          <a:bodyPr wrap="square" lIns="0" tIns="0" rIns="0" bIns="0" rtlCol="0" anchor="t"/>
+          <a:lstStyle/>
+          <a:p>
+            <a:pPr algn="ctr" indent="0" marL="0">
+              <a:spcAft>
+                <a:spcPts val="400"/>
+              </a:spcAft>
+              <a:buNone/>
+            </a:pPr>
+            <a:r>
+              <a:rPr lang="en-US" sz="1100" dirty="0">
+                <a:solidFill>
+                  <a:srgbClr val="4B5563"/>
+                </a:solidFill>
+                <a:latin typeface="Trebuchet MS" pitchFamily="34" charset="0"/>
+                <a:ea typeface="Trebuchet MS" pitchFamily="34" charset="-122"/>
+                <a:cs typeface="Trebuchet MS" pitchFamily="34" charset="-120"/>
+              </a:rPr>
+              <a:t>Accuracy in voxel-level 3D semantic mapping and active sensor fusion.</a:t>
+            </a:r>
+            <a:endParaRPr lang="en-US" sz="1100" dirty="0"/>
+          </a:p>
+        </p:txBody>
+      </p:sp>
+      <p:sp>
+        <p:nvSpPr>
+          <p:cNvPr id="13" name="Shape 11"/>
+          <p:cNvSpPr/>
+          <p:nvPr/>
+        </p:nvSpPr>
+        <p:spPr>
+          <a:xfrm>
+            <a:off x="4419600" y="1463040"/>
+            <a:ext cx="3322320" cy="4389120"/>
+          </a:xfrm>
+          <a:prstGeom prst="roundRect">
+            <a:avLst/>
+          </a:prstGeom>
+          <a:solidFill>
+            <a:srgbClr val="FFFFFF"/>
+          </a:solidFill>
+          <a:ln w="19050">
+            <a:solidFill>
+              <a:srgbClr val="E9D5FF"/>
+            </a:solidFill>
+            <a:prstDash val="solid"/>
+          </a:ln>
+        </p:spPr>
+      </p:sp>
+      <p:sp>
+        <p:nvSpPr>
+          <p:cNvPr id="14" name="Shape 12"/>
+          <p:cNvSpPr/>
+          <p:nvPr/>
+        </p:nvSpPr>
+        <p:spPr>
+          <a:xfrm>
+            <a:off x="4419600" y="1463040"/>
+            <a:ext cx="3322320" cy="73152"/>
+          </a:xfrm>
+          <a:prstGeom prst="rect">
+            <a:avLst/>
+          </a:prstGeom>
+          <a:solidFill>
+            <a:srgbClr val="D946EF"/>
+          </a:solidFill>
+          <a:ln/>
+        </p:spPr>
+      </p:sp>
+      <p:sp>
+        <p:nvSpPr>
+          <p:cNvPr id="15" name="Text 13"/>
+          <p:cNvSpPr/>
+          <p:nvPr/>
+        </p:nvSpPr>
+        <p:spPr>
+          <a:xfrm>
+            <a:off x="4511040" y="1783080"/>
+            <a:ext cx="3139440" cy="822960"/>
+          </a:xfrm>
+          <a:prstGeom prst="rect">
+            <a:avLst/>
+          </a:prstGeom>
+          <a:noFill/>
+          <a:ln/>
+        </p:spPr>
+        <p:txBody>
+          <a:bodyPr wrap="square" lIns="0" tIns="0" rIns="0" bIns="0" rtlCol="0" anchor="ctr"/>
+          <a:lstStyle/>
+          <a:p>
+            <a:pPr algn="ctr" indent="0" marL="0">
+              <a:buNone/>
+            </a:pPr>
+            <a:r>
+              <a:rPr lang="en-US" sz="3800" b="1" dirty="0">
+                <a:solidFill>
+                  <a:srgbClr val="D946EF"/>
+                </a:solidFill>
+                <a:latin typeface="Georgia, 'Microsoft YaHei', serif" pitchFamily="34" charset="0"/>
+                <a:ea typeface="Georgia, 'Microsoft YaHei', serif" pitchFamily="34" charset="-122"/>
+                <a:cs typeface="Georgia, 'Microsoft YaHei', serif" pitchFamily="34" charset="-120"/>
+              </a:rPr>
+              <a:t>12.5x</a:t>
+            </a:r>
+            <a:endParaRPr lang="en-US" sz="3800" dirty="0"/>
+          </a:p>
+        </p:txBody>
+      </p:sp>
+      <p:sp>
+        <p:nvSpPr>
+          <p:cNvPr id="16" name="Text 14"/>
+          <p:cNvSpPr/>
+          <p:nvPr/>
+        </p:nvSpPr>
+        <p:spPr>
+          <a:xfrm>
+            <a:off x="4602480" y="2697480"/>
+            <a:ext cx="2956560" cy="3017520"/>
+          </a:xfrm>
+          <a:prstGeom prst="rect">
+            <a:avLst/>
+          </a:prstGeom>
+          <a:noFill/>
+          <a:ln/>
+        </p:spPr>
+        <p:txBody>
+          <a:bodyPr wrap="square" lIns="0" tIns="0" rIns="0" bIns="0" rtlCol="0" anchor="t"/>
+          <a:lstStyle/>
+          <a:p>
+            <a:pPr algn="ctr" indent="0" marL="0">
+              <a:spcAft>
+                <a:spcPts val="400"/>
+              </a:spcAft>
+              <a:buNone/>
+            </a:pPr>
+            <a:r>
+              <a:rPr lang="en-US" sz="1100" dirty="0">
+                <a:solidFill>
+                  <a:srgbClr val="4B5563"/>
+                </a:solidFill>
+                <a:latin typeface="Trebuchet MS" pitchFamily="34" charset="0"/>
+                <a:ea typeface="Trebuchet MS" pitchFamily="34" charset="-122"/>
+                <a:cs typeface="Trebuchet MS" pitchFamily="34" charset="-120"/>
+              </a:rPr>
+              <a:t>Speedup in sim-to-real transfer with zero-shot domain randomization.</a:t>
+            </a:r>
+            <a:endParaRPr lang="en-US" sz="1100" dirty="0"/>
+          </a:p>
+        </p:txBody>
+      </p:sp>
+      <p:sp>
+        <p:nvSpPr>
+          <p:cNvPr id="17" name="Shape 15"/>
+          <p:cNvSpPr/>
+          <p:nvPr/>
+        </p:nvSpPr>
+        <p:spPr>
+          <a:xfrm>
+            <a:off x="8107680" y="1463040"/>
+            <a:ext cx="3322320" cy="4389120"/>
+          </a:xfrm>
+          <a:prstGeom prst="roundRect">
+            <a:avLst/>
+          </a:prstGeom>
+          <a:solidFill>
+            <a:srgbClr val="FFFFFF"/>
+          </a:solidFill>
+          <a:ln w="19050">
+            <a:solidFill>
+              <a:srgbClr val="E9D5FF"/>
+            </a:solidFill>
+            <a:prstDash val="solid"/>
+          </a:ln>
+        </p:spPr>
+      </p:sp>
+      <p:sp>
+        <p:nvSpPr>
+          <p:cNvPr id="18" name="Shape 16"/>
+          <p:cNvSpPr/>
+          <p:nvPr/>
+        </p:nvSpPr>
+        <p:spPr>
+          <a:xfrm>
+            <a:off x="8107680" y="1463040"/>
+            <a:ext cx="3322320" cy="73152"/>
+          </a:xfrm>
+          <a:prstGeom prst="rect">
+            <a:avLst/>
+          </a:prstGeom>
+          <a:solidFill>
+            <a:srgbClr val="D946EF"/>
+          </a:solidFill>
+          <a:ln/>
+        </p:spPr>
+      </p:sp>
+      <p:sp>
+        <p:nvSpPr>
+          <p:cNvPr id="19" name="Text 17"/>
+          <p:cNvSpPr/>
+          <p:nvPr/>
+        </p:nvSpPr>
+        <p:spPr>
+          <a:xfrm>
+            <a:off x="8199120" y="1783080"/>
+            <a:ext cx="3139440" cy="822960"/>
+          </a:xfrm>
+          <a:prstGeom prst="rect">
+            <a:avLst/>
+          </a:prstGeom>
+          <a:noFill/>
+          <a:ln/>
+        </p:spPr>
+        <p:txBody>
+          <a:bodyPr wrap="square" lIns="0" tIns="0" rIns="0" bIns="0" rtlCol="0" anchor="ctr"/>
+          <a:lstStyle/>
+          <a:p>
+            <a:pPr algn="ctr" indent="0" marL="0">
+              <a:buNone/>
+            </a:pPr>
+            <a:r>
+              <a:rPr lang="en-US" sz="3800" b="1" dirty="0">
+                <a:solidFill>
+                  <a:srgbClr val="D946EF"/>
+                </a:solidFill>
+                <a:latin typeface="Georgia, 'Microsoft YaHei', serif" pitchFamily="34" charset="0"/>
+                <a:ea typeface="Georgia, 'Microsoft YaHei', serif" pitchFamily="34" charset="-122"/>
+                <a:cs typeface="Georgia, 'Microsoft YaHei', serif" pitchFamily="34" charset="-120"/>
+              </a:rPr>
+              <a:t>-35%</a:t>
+            </a:r>
+            <a:endParaRPr lang="en-US" sz="3800" dirty="0"/>
+          </a:p>
+        </p:txBody>
+      </p:sp>
+      <p:sp>
+        <p:nvSpPr>
+          <p:cNvPr id="20" name="Text 18"/>
+          <p:cNvSpPr/>
+          <p:nvPr/>
+        </p:nvSpPr>
+        <p:spPr>
+          <a:xfrm>
+            <a:off x="8290560" y="2697480"/>
+            <a:ext cx="2956560" cy="3017520"/>
+          </a:xfrm>
+          <a:prstGeom prst="rect">
+            <a:avLst/>
+          </a:prstGeom>
+          <a:noFill/>
+          <a:ln/>
+        </p:spPr>
+        <p:txBody>
+          <a:bodyPr wrap="square" lIns="0" tIns="0" rIns="0" bIns="0" rtlCol="0" anchor="t"/>
+          <a:lstStyle/>
+          <a:p>
+            <a:pPr algn="ctr" indent="0" marL="0">
+              <a:spcAft>
+                <a:spcPts val="400"/>
+              </a:spcAft>
+              <a:buNone/>
+            </a:pPr>
+            <a:r>
+              <a:rPr lang="en-US" sz="1100" dirty="0">
+                <a:solidFill>
+                  <a:srgbClr val="4B5563"/>
+                </a:solidFill>
+                <a:latin typeface="Trebuchet MS" pitchFamily="34" charset="0"/>
+                <a:ea typeface="Trebuchet MS" pitchFamily="34" charset="-122"/>
+                <a:cs typeface="Trebuchet MS" pitchFamily="34" charset="-120"/>
+              </a:rPr>
+              <a:t>Collision rates in crowded dynamic obstacle environments.</a:t>
+            </a:r>
+            <a:endParaRPr lang="en-US" sz="1100" dirty="0"/>
+          </a:p>
+        </p:txBody>
+      </p:sp>
+    </p:spTree>
+  </p:cSld>
+  <p:clrMapOvr>
+    <a:masterClrMapping/>
+  </p:clrMapOvr>
+</p:sld>
+</file>
+
+<file path=ppt/slides/slide7.xml><?xml version="1.0" encoding="utf-8"?>
+<p:sld xmlns:a="http://schemas.openxmlformats.org/drawingml/2006/main" xmlns:r="http://schemas.openxmlformats.org/officeDocument/2006/relationships" xmlns:p="http://schemas.openxmlformats.org/presentationml/2006/main">
+  <p:cSld name="Slide 7">
+    <p:bg>
+      <p:bgPr>
+        <a:solidFill>
+          <a:srgbClr val="FAF5FF"/>
+        </a:solidFill>
+      </p:bgPr>
+    </p:bg>
+    <p:spTree>
+      <p:nvGrpSpPr>
+        <p:cNvPr id="1" name=""/>
+        <p:cNvGrpSpPr/>
+        <p:nvPr/>
+      </p:nvGrpSpPr>
+      <p:grpSpPr>
+        <a:xfrm>
+          <a:off x="0" y="0"/>
+          <a:ext cx="0" cy="0"/>
+          <a:chOff x="0" y="0"/>
+          <a:chExt cx="0" cy="0"/>
+        </a:xfrm>
+      </p:grpSpPr>
+      <p:sp>
+        <p:nvSpPr>
+          <p:cNvPr id="2" name="Text 0"/>
+          <p:cNvSpPr/>
+          <p:nvPr/>
+        </p:nvSpPr>
+        <p:spPr>
+          <a:xfrm>
+            <a:off x="731520" y="137160"/>
+            <a:ext cx="5486400" cy="228600"/>
+          </a:xfrm>
+          <a:prstGeom prst="rect">
+            <a:avLst/>
+          </a:prstGeom>
+          <a:noFill/>
+          <a:ln/>
+        </p:spPr>
+        <p:txBody>
+          <a:bodyPr wrap="square" lIns="0" tIns="0" rIns="0" bIns="0" rtlCol="0" anchor="ctr"/>
+          <a:lstStyle/>
+          <a:p>
+            <a:pPr algn="l" indent="0" marL="0">
+              <a:buNone/>
+            </a:pPr>
+            <a:r>
+              <a:rPr lang="en-US" sz="900" b="1" dirty="0">
+                <a:solidFill>
+                  <a:srgbClr val="4B5563"/>
+                </a:solidFill>
+                <a:latin typeface="Trebuchet MS" pitchFamily="34" charset="0"/>
+                <a:ea typeface="Trebuchet MS" pitchFamily="34" charset="-122"/>
+                <a:cs typeface="Trebuchet MS" pitchFamily="34" charset="-120"/>
+              </a:rPr>
+              <a:t>SLIDE 06 | EMBODIED &amp; SPATIAL AI</a:t>
+            </a:r>
+            <a:endParaRPr lang="en-US" sz="900" dirty="0"/>
+          </a:p>
+        </p:txBody>
+      </p:sp>
+      <p:sp>
+        <p:nvSpPr>
+          <p:cNvPr id="3" name="Shape 1"/>
+          <p:cNvSpPr/>
+          <p:nvPr/>
+        </p:nvSpPr>
+        <p:spPr>
+          <a:xfrm>
+            <a:off x="11064240" y="210312"/>
+            <a:ext cx="73152" cy="73152"/>
+          </a:xfrm>
+          <a:prstGeom prst="oval">
+            <a:avLst/>
+          </a:prstGeom>
+          <a:solidFill>
+            <a:srgbClr val="FF5F56"/>
+          </a:solidFill>
+          <a:ln/>
+        </p:spPr>
+      </p:sp>
+      <p:sp>
+        <p:nvSpPr>
+          <p:cNvPr id="4" name="Shape 2"/>
+          <p:cNvSpPr/>
+          <p:nvPr/>
+        </p:nvSpPr>
+        <p:spPr>
+          <a:xfrm>
+            <a:off x="11173968" y="210312"/>
+            <a:ext cx="73152" cy="73152"/>
+          </a:xfrm>
+          <a:prstGeom prst="oval">
+            <a:avLst/>
+          </a:prstGeom>
+          <a:solidFill>
+            <a:srgbClr val="FFBD2E"/>
+          </a:solidFill>
+          <a:ln/>
+        </p:spPr>
+      </p:sp>
+      <p:sp>
+        <p:nvSpPr>
+          <p:cNvPr id="5" name="Shape 3"/>
+          <p:cNvSpPr/>
+          <p:nvPr/>
+        </p:nvSpPr>
+        <p:spPr>
+          <a:xfrm>
+            <a:off x="11283696" y="210312"/>
+            <a:ext cx="73152" cy="73152"/>
+          </a:xfrm>
+          <a:prstGeom prst="oval">
+            <a:avLst/>
+          </a:prstGeom>
+          <a:solidFill>
+            <a:srgbClr val="27C93F"/>
+          </a:solidFill>
+          <a:ln/>
+        </p:spPr>
+      </p:sp>
+      <p:sp>
+        <p:nvSpPr>
+          <p:cNvPr id="6" name="Shape 4"/>
+          <p:cNvSpPr/>
+          <p:nvPr/>
+        </p:nvSpPr>
+        <p:spPr>
+          <a:xfrm>
+            <a:off x="731520" y="502920"/>
+            <a:ext cx="109728" cy="457200"/>
+          </a:xfrm>
+          <a:prstGeom prst="rect">
+            <a:avLst/>
+          </a:prstGeom>
+          <a:solidFill>
+            <a:srgbClr val="D946EF"/>
+          </a:solidFill>
+          <a:ln/>
+        </p:spPr>
+      </p:sp>
+      <p:sp>
+        <p:nvSpPr>
+          <p:cNvPr id="7" name="Text 5"/>
+          <p:cNvSpPr/>
+          <p:nvPr/>
+        </p:nvSpPr>
+        <p:spPr>
+          <a:xfrm>
+            <a:off x="960120" y="365760"/>
+            <a:ext cx="10469880" cy="731520"/>
+          </a:xfrm>
+          <a:prstGeom prst="rect">
+            <a:avLst/>
+          </a:prstGeom>
+          <a:noFill/>
+          <a:ln/>
+        </p:spPr>
+        <p:txBody>
+          <a:bodyPr wrap="square" lIns="0" tIns="0" rIns="0" bIns="0" rtlCol="0" anchor="ctr"/>
+          <a:lstStyle/>
+          <a:p>
+            <a:pPr indent="0" marL="0">
+              <a:buNone/>
+            </a:pPr>
+            <a:r>
+              <a:rPr lang="en-US" sz="2800" b="1" dirty="0">
+                <a:solidFill>
+                  <a:srgbClr val="7C3AED"/>
+                </a:solidFill>
+                <a:latin typeface="Trebuchet MS" pitchFamily="34" charset="0"/>
+                <a:ea typeface="Trebuchet MS" pitchFamily="34" charset="-122"/>
+                <a:cs typeface="Trebuchet MS" pitchFamily="34" charset="-120"/>
+              </a:rPr>
+              <a:t>Simulation vs Physical Contrast</a:t>
+            </a:r>
+            <a:endParaRPr lang="en-US" sz="2800" dirty="0"/>
+          </a:p>
+        </p:txBody>
+      </p:sp>
+      <p:sp>
+        <p:nvSpPr>
+          <p:cNvPr id="8" name="Shape 6"/>
+          <p:cNvSpPr/>
+          <p:nvPr/>
+        </p:nvSpPr>
+        <p:spPr>
+          <a:xfrm>
+            <a:off x="731520" y="1143000"/>
+            <a:ext cx="10698480" cy="0"/>
+          </a:xfrm>
+          <a:prstGeom prst="line">
+            <a:avLst/>
+          </a:prstGeom>
+          <a:noFill/>
+          <a:ln w="19050">
+            <a:solidFill>
+              <a:srgbClr val="E9D5FF"/>
+            </a:solidFill>
+            <a:prstDash val="solid"/>
+          </a:ln>
+        </p:spPr>
+      </p:sp>
+      <p:sp>
+        <p:nvSpPr>
+          <p:cNvPr id="9" name="Shape 7"/>
+          <p:cNvSpPr/>
+          <p:nvPr/>
+        </p:nvSpPr>
+        <p:spPr>
+          <a:xfrm>
+            <a:off x="731520" y="1463040"/>
+            <a:ext cx="5166360" cy="4389120"/>
+          </a:xfrm>
+          <a:prstGeom prst="roundRect">
+            <a:avLst/>
+          </a:prstGeom>
+          <a:solidFill>
+            <a:srgbClr val="FFFFFF"/>
+          </a:solidFill>
+          <a:ln w="19050">
+            <a:solidFill>
+              <a:srgbClr val="E9D5FF"/>
+            </a:solidFill>
+            <a:prstDash val="solid"/>
+          </a:ln>
+        </p:spPr>
+      </p:sp>
+      <p:sp>
+        <p:nvSpPr>
+          <p:cNvPr id="10" name="Shape 8"/>
+          <p:cNvSpPr/>
+          <p:nvPr/>
+        </p:nvSpPr>
+        <p:spPr>
+          <a:xfrm>
+            <a:off x="731520" y="1463040"/>
+            <a:ext cx="5166360" cy="73152"/>
+          </a:xfrm>
+          <a:prstGeom prst="rect">
+            <a:avLst/>
+          </a:prstGeom>
+          <a:solidFill>
+            <a:srgbClr val="10B981"/>
+          </a:solidFill>
+          <a:ln/>
+        </p:spPr>
+      </p:sp>
+      <p:sp>
+        <p:nvSpPr>
+          <p:cNvPr id="11" name="Text 9"/>
+          <p:cNvSpPr/>
+          <p:nvPr/>
+        </p:nvSpPr>
+        <p:spPr>
+          <a:xfrm>
+            <a:off x="731520" y="1691640"/>
+            <a:ext cx="5166360" cy="457200"/>
+          </a:xfrm>
+          <a:prstGeom prst="rect">
+            <a:avLst/>
+          </a:prstGeom>
+          <a:noFill/>
+          <a:ln/>
+        </p:spPr>
+        <p:txBody>
+          <a:bodyPr wrap="square" rtlCol="0" anchor="ctr"/>
+          <a:lstStyle/>
+          <a:p>
+            <a:pPr algn="ctr" indent="0" marL="0">
+              <a:buNone/>
+            </a:pPr>
+            <a:r>
+              <a:rPr lang="en-US" sz="2400" dirty="0">
+                <a:solidFill>
+                  <a:srgbClr val="000000"/>
+                </a:solidFill>
+              </a:rPr>
+              <a:t>🔹</a:t>
+            </a:r>
+            <a:endParaRPr lang="en-US" sz="2400" dirty="0"/>
+          </a:p>
+        </p:txBody>
+      </p:sp>
+      <p:sp>
+        <p:nvSpPr>
+          <p:cNvPr id="12" name="Text 10"/>
+          <p:cNvSpPr/>
+          <p:nvPr/>
+        </p:nvSpPr>
+        <p:spPr>
+          <a:xfrm>
+            <a:off x="822960" y="2194560"/>
+            <a:ext cx="4983480" cy="365760"/>
+          </a:xfrm>
+          <a:prstGeom prst="rect">
+            <a:avLst/>
+          </a:prstGeom>
+          <a:noFill/>
+          <a:ln/>
+        </p:spPr>
+        <p:txBody>
+          <a:bodyPr wrap="square" lIns="0" tIns="0" rIns="0" bIns="0" rtlCol="0" anchor="ctr"/>
+          <a:lstStyle/>
+          <a:p>
+            <a:pPr algn="ctr" indent="0" marL="0">
+              <a:buNone/>
+            </a:pPr>
+            <a:r>
+              <a:rPr lang="en-US" sz="1400" b="1" dirty="0">
+                <a:solidFill>
+                  <a:srgbClr val="7C3AED"/>
+                </a:solidFill>
+                <a:latin typeface="Trebuchet MS" pitchFamily="34" charset="0"/>
+                <a:ea typeface="Trebuchet MS" pitchFamily="34" charset="-122"/>
+                <a:cs typeface="Trebuchet MS" pitchFamily="34" charset="-120"/>
+              </a:rPr>
+              <a:t>Simulation Environment</a:t>
+            </a:r>
+            <a:endParaRPr lang="en-US" sz="1400" dirty="0"/>
+          </a:p>
+        </p:txBody>
+      </p:sp>
+      <p:sp>
+        <p:nvSpPr>
+          <p:cNvPr id="13" name="Text 11"/>
+          <p:cNvSpPr/>
+          <p:nvPr/>
+        </p:nvSpPr>
+        <p:spPr>
+          <a:xfrm>
+            <a:off x="914400" y="2697480"/>
+            <a:ext cx="4800600" cy="3017520"/>
+          </a:xfrm>
+          <a:prstGeom prst="rect">
+            <a:avLst/>
+          </a:prstGeom>
+          <a:noFill/>
+          <a:ln/>
+        </p:spPr>
+        <p:txBody>
+          <a:bodyPr wrap="square" lIns="0" tIns="0" rIns="0" bIns="0" rtlCol="0" anchor="t"/>
+          <a:lstStyle/>
+          <a:p>
+            <a:pPr indent="0" marL="0">
+              <a:spcAft>
+                <a:spcPts val="400"/>
+              </a:spcAft>
+              <a:buNone/>
+            </a:pPr>
+            <a:r>
+              <a:rPr lang="en-US" sz="1100" dirty="0">
+                <a:solidFill>
+                  <a:srgbClr val="4B5563"/>
+                </a:solidFill>
+                <a:latin typeface="Trebuchet MS" pitchFamily="34" charset="0"/>
+                <a:ea typeface="Trebuchet MS" pitchFamily="34" charset="-122"/>
+                <a:cs typeface="Trebuchet MS" pitchFamily="34" charset="-120"/>
+              </a:rPr>
+              <a:t>Photorealistic virtual domain, zero hardware risk, infinite parallel rollouts, perfect sensor measurements.</a:t>
+            </a:r>
+            <a:endParaRPr lang="en-US" sz="1100" dirty="0"/>
+          </a:p>
+        </p:txBody>
+      </p:sp>
+      <p:sp>
+        <p:nvSpPr>
+          <p:cNvPr id="14" name="Shape 12"/>
+          <p:cNvSpPr/>
+          <p:nvPr/>
+        </p:nvSpPr>
+        <p:spPr>
+          <a:xfrm>
+            <a:off x="6263640" y="1463040"/>
+            <a:ext cx="5166360" cy="4389120"/>
+          </a:xfrm>
+          <a:prstGeom prst="roundRect">
+            <a:avLst/>
+          </a:prstGeom>
+          <a:solidFill>
+            <a:srgbClr val="FFFFFF"/>
+          </a:solidFill>
+          <a:ln w="19050">
+            <a:solidFill>
+              <a:srgbClr val="E9D5FF"/>
+            </a:solidFill>
+            <a:prstDash val="solid"/>
+          </a:ln>
+        </p:spPr>
+      </p:sp>
+      <p:sp>
+        <p:nvSpPr>
+          <p:cNvPr id="15" name="Shape 13"/>
+          <p:cNvSpPr/>
+          <p:nvPr/>
+        </p:nvSpPr>
+        <p:spPr>
+          <a:xfrm>
+            <a:off x="6263640" y="1463040"/>
+            <a:ext cx="5166360" cy="73152"/>
+          </a:xfrm>
+          <a:prstGeom prst="rect">
+            <a:avLst/>
+          </a:prstGeom>
+          <a:solidFill>
+            <a:srgbClr val="EF4444"/>
+          </a:solidFill>
+          <a:ln/>
+        </p:spPr>
+      </p:sp>
+      <p:sp>
+        <p:nvSpPr>
+          <p:cNvPr id="16" name="Text 14"/>
+          <p:cNvSpPr/>
+          <p:nvPr/>
+        </p:nvSpPr>
+        <p:spPr>
+          <a:xfrm>
+            <a:off x="6263640" y="1691640"/>
+            <a:ext cx="5166360" cy="457200"/>
+          </a:xfrm>
+          <a:prstGeom prst="rect">
+            <a:avLst/>
+          </a:prstGeom>
+          <a:noFill/>
+          <a:ln/>
+        </p:spPr>
+        <p:txBody>
+          <a:bodyPr wrap="square" rtlCol="0" anchor="ctr"/>
+          <a:lstStyle/>
+          <a:p>
+            <a:pPr algn="ctr" indent="0" marL="0">
+              <a:buNone/>
+            </a:pPr>
+            <a:r>
+              <a:rPr lang="en-US" sz="2400" dirty="0">
+                <a:solidFill>
+                  <a:srgbClr val="000000"/>
+                </a:solidFill>
+              </a:rPr>
+              <a:t>🔹</a:t>
+            </a:r>
+            <a:endParaRPr lang="en-US" sz="2400" dirty="0"/>
+          </a:p>
+        </p:txBody>
+      </p:sp>
+      <p:sp>
+        <p:nvSpPr>
+          <p:cNvPr id="17" name="Text 15"/>
+          <p:cNvSpPr/>
+          <p:nvPr/>
+        </p:nvSpPr>
+        <p:spPr>
+          <a:xfrm>
+            <a:off x="6355080" y="2194560"/>
+            <a:ext cx="4983480" cy="365760"/>
+          </a:xfrm>
+          <a:prstGeom prst="rect">
+            <a:avLst/>
+          </a:prstGeom>
+          <a:noFill/>
+          <a:ln/>
+        </p:spPr>
+        <p:txBody>
+          <a:bodyPr wrap="square" lIns="0" tIns="0" rIns="0" bIns="0" rtlCol="0" anchor="ctr"/>
+          <a:lstStyle/>
+          <a:p>
+            <a:pPr algn="ctr" indent="0" marL="0">
+              <a:buNone/>
+            </a:pPr>
+            <a:r>
+              <a:rPr lang="en-US" sz="1400" b="1" dirty="0">
+                <a:solidFill>
+                  <a:srgbClr val="7C3AED"/>
+                </a:solidFill>
+                <a:latin typeface="Trebuchet MS" pitchFamily="34" charset="0"/>
+                <a:ea typeface="Trebuchet MS" pitchFamily="34" charset="-122"/>
+                <a:cs typeface="Trebuchet MS" pitchFamily="34" charset="-120"/>
+              </a:rPr>
+              <a:t>Physical Real World</a:t>
+            </a:r>
+            <a:endParaRPr lang="en-US" sz="1400" dirty="0"/>
+          </a:p>
+        </p:txBody>
+      </p:sp>
+      <p:sp>
+        <p:nvSpPr>
+          <p:cNvPr id="18" name="Text 16"/>
+          <p:cNvSpPr/>
+          <p:nvPr/>
+        </p:nvSpPr>
+        <p:spPr>
+          <a:xfrm>
+            <a:off x="6446520" y="2697480"/>
+            <a:ext cx="4800600" cy="3017520"/>
+          </a:xfrm>
+          <a:prstGeom prst="rect">
+            <a:avLst/>
+          </a:prstGeom>
+          <a:noFill/>
+          <a:ln/>
+        </p:spPr>
+        <p:txBody>
+          <a:bodyPr wrap="square" lIns="0" tIns="0" rIns="0" bIns="0" rtlCol="0" anchor="t"/>
+          <a:lstStyle/>
+          <a:p>
+            <a:pPr indent="0" marL="0">
+              <a:spcAft>
+                <a:spcPts val="400"/>
+              </a:spcAft>
+              <a:buNone/>
+            </a:pPr>
+            <a:r>
+              <a:rPr lang="en-US" sz="1100" dirty="0">
+                <a:solidFill>
+                  <a:srgbClr val="4B5563"/>
+                </a:solidFill>
+                <a:latin typeface="Trebuchet MS" pitchFamily="34" charset="0"/>
+                <a:ea typeface="Trebuchet MS" pitchFamily="34" charset="-122"/>
+                <a:cs typeface="Trebuchet MS" pitchFamily="34" charset="-120"/>
+              </a:rPr>
+              <a:t>Noisy real-world sensors, mechanical wear and lag, high collision risks, limited execution speed.</a:t>
+            </a:r>
+            <a:endParaRPr lang="en-US" sz="1100" dirty="0"/>
+          </a:p>
+        </p:txBody>
+      </p:sp>
+    </p:spTree>
+  </p:cSld>
+  <p:clrMapOvr>
+    <a:masterClrMapping/>
+  </p:clrMapOvr>
+</p:sld>
+</file>
+
+<file path=ppt/slides/slide8.xml><?xml version="1.0" encoding="utf-8"?>
+<p:sld xmlns:a="http://schemas.openxmlformats.org/drawingml/2006/main" xmlns:r="http://schemas.openxmlformats.org/officeDocument/2006/relationships" xmlns:p="http://schemas.openxmlformats.org/presentationml/2006/main">
+  <p:cSld name="Slide 8">
+    <p:bg>
+      <p:bgPr>
+        <a:solidFill>
+          <a:srgbClr val="FAF5FF"/>
+        </a:solidFill>
+      </p:bgPr>
+    </p:bg>
+    <p:spTree>
+      <p:nvGrpSpPr>
+        <p:cNvPr id="1" name=""/>
+        <p:cNvGrpSpPr/>
+        <p:nvPr/>
+      </p:nvGrpSpPr>
+      <p:grpSpPr>
+        <a:xfrm>
+          <a:off x="0" y="0"/>
+          <a:ext cx="0" cy="0"/>
+          <a:chOff x="0" y="0"/>
+          <a:chExt cx="0" cy="0"/>
+        </a:xfrm>
+      </p:grpSpPr>
+      <p:sp>
+        <p:nvSpPr>
+          <p:cNvPr id="2" name="Text 0"/>
+          <p:cNvSpPr/>
+          <p:nvPr/>
+        </p:nvSpPr>
+        <p:spPr>
+          <a:xfrm>
+            <a:off x="731520" y="137160"/>
+            <a:ext cx="5486400" cy="228600"/>
+          </a:xfrm>
+          <a:prstGeom prst="rect">
+            <a:avLst/>
+          </a:prstGeom>
+          <a:noFill/>
+          <a:ln/>
+        </p:spPr>
+        <p:txBody>
+          <a:bodyPr wrap="square" lIns="0" tIns="0" rIns="0" bIns="0" rtlCol="0" anchor="ctr"/>
+          <a:lstStyle/>
+          <a:p>
+            <a:pPr algn="l" indent="0" marL="0">
+              <a:buNone/>
+            </a:pPr>
+            <a:r>
+              <a:rPr lang="en-US" sz="900" b="1" dirty="0">
+                <a:solidFill>
+                  <a:srgbClr val="4B5563"/>
+                </a:solidFill>
+                <a:latin typeface="Trebuchet MS" pitchFamily="34" charset="0"/>
+                <a:ea typeface="Trebuchet MS" pitchFamily="34" charset="-122"/>
+                <a:cs typeface="Trebuchet MS" pitchFamily="34" charset="-120"/>
+              </a:rPr>
+              <a:t>SLIDE 07 | EMBODIED &amp; SPATIAL AI</a:t>
+            </a:r>
+            <a:endParaRPr lang="en-US" sz="900" dirty="0"/>
+          </a:p>
+        </p:txBody>
+      </p:sp>
+      <p:sp>
+        <p:nvSpPr>
+          <p:cNvPr id="3" name="Shape 1"/>
+          <p:cNvSpPr/>
+          <p:nvPr/>
+        </p:nvSpPr>
+        <p:spPr>
+          <a:xfrm>
+            <a:off x="11064240" y="210312"/>
+            <a:ext cx="73152" cy="73152"/>
+          </a:xfrm>
+          <a:prstGeom prst="oval">
+            <a:avLst/>
+          </a:prstGeom>
+          <a:solidFill>
+            <a:srgbClr val="FF5F56"/>
+          </a:solidFill>
+          <a:ln/>
+        </p:spPr>
+      </p:sp>
+      <p:sp>
+        <p:nvSpPr>
+          <p:cNvPr id="4" name="Shape 2"/>
+          <p:cNvSpPr/>
+          <p:nvPr/>
+        </p:nvSpPr>
+        <p:spPr>
+          <a:xfrm>
+            <a:off x="11173968" y="210312"/>
+            <a:ext cx="73152" cy="73152"/>
+          </a:xfrm>
+          <a:prstGeom prst="oval">
+            <a:avLst/>
+          </a:prstGeom>
+          <a:solidFill>
+            <a:srgbClr val="FFBD2E"/>
+          </a:solidFill>
+          <a:ln/>
+        </p:spPr>
+      </p:sp>
+      <p:sp>
+        <p:nvSpPr>
+          <p:cNvPr id="5" name="Shape 3"/>
+          <p:cNvSpPr/>
+          <p:nvPr/>
+        </p:nvSpPr>
+        <p:spPr>
+          <a:xfrm>
+            <a:off x="11283696" y="210312"/>
+            <a:ext cx="73152" cy="73152"/>
+          </a:xfrm>
+          <a:prstGeom prst="oval">
+            <a:avLst/>
+          </a:prstGeom>
+          <a:solidFill>
+            <a:srgbClr val="27C93F"/>
+          </a:solidFill>
+          <a:ln/>
+        </p:spPr>
+      </p:sp>
+      <p:sp>
+        <p:nvSpPr>
+          <p:cNvPr id="6" name="Shape 4"/>
+          <p:cNvSpPr/>
+          <p:nvPr/>
+        </p:nvSpPr>
+        <p:spPr>
+          <a:xfrm>
+            <a:off x="731520" y="502920"/>
+            <a:ext cx="109728" cy="457200"/>
+          </a:xfrm>
+          <a:prstGeom prst="rect">
+            <a:avLst/>
+          </a:prstGeom>
+          <a:solidFill>
+            <a:srgbClr val="D946EF"/>
+          </a:solidFill>
+          <a:ln/>
+        </p:spPr>
+      </p:sp>
+      <p:sp>
+        <p:nvSpPr>
+          <p:cNvPr id="7" name="Text 5"/>
+          <p:cNvSpPr/>
+          <p:nvPr/>
+        </p:nvSpPr>
+        <p:spPr>
+          <a:xfrm>
+            <a:off x="960120" y="365760"/>
+            <a:ext cx="10469880" cy="731520"/>
+          </a:xfrm>
+          <a:prstGeom prst="rect">
+            <a:avLst/>
+          </a:prstGeom>
+          <a:noFill/>
+          <a:ln/>
+        </p:spPr>
+        <p:txBody>
+          <a:bodyPr wrap="square" lIns="0" tIns="0" rIns="0" bIns="0" rtlCol="0" anchor="ctr"/>
+          <a:lstStyle/>
+          <a:p>
+            <a:pPr indent="0" marL="0">
+              <a:buNone/>
+            </a:pPr>
+            <a:r>
+              <a:rPr lang="en-US" sz="2800" b="1" dirty="0">
+                <a:solidFill>
+                  <a:srgbClr val="7C3AED"/>
+                </a:solidFill>
+                <a:latin typeface="Trebuchet MS" pitchFamily="34" charset="0"/>
+                <a:ea typeface="Trebuchet MS" pitchFamily="34" charset="-122"/>
+                <a:cs typeface="Trebuchet MS" pitchFamily="34" charset="-120"/>
+              </a:rPr>
+              <a:t>Latency Benchmark</a:t>
+            </a:r>
+            <a:endParaRPr lang="en-US" sz="2800" dirty="0"/>
+          </a:p>
+        </p:txBody>
+      </p:sp>
+      <p:sp>
+        <p:nvSpPr>
+          <p:cNvPr id="8" name="Shape 6"/>
+          <p:cNvSpPr/>
+          <p:nvPr/>
+        </p:nvSpPr>
+        <p:spPr>
+          <a:xfrm>
+            <a:off x="731520" y="1143000"/>
+            <a:ext cx="10698480" cy="0"/>
+          </a:xfrm>
+          <a:prstGeom prst="line">
+            <a:avLst/>
+          </a:prstGeom>
+          <a:noFill/>
+          <a:ln w="19050">
+            <a:solidFill>
+              <a:srgbClr val="E9D5FF"/>
+            </a:solidFill>
+            <a:prstDash val="solid"/>
+          </a:ln>
+        </p:spPr>
+      </p:sp>
+      <p:graphicFrame>
+        <p:nvGraphicFramePr>
+          <p:cNvPr id="9" name="Chart 0" descr=""/>
+          <p:cNvGraphicFramePr/>
+          <p:nvPr/>
+        </p:nvGraphicFramePr>
+        <p:xfrm>
+          <a:off x="914400" y="1463040"/>
+          <a:ext cx="10332720" cy="4389120"/>
+        </p:xfrm>
+        <a:graphic xmlns:a="http://schemas.openxmlformats.org/drawingml/2006/main">
+          <a:graphicData uri="http://schemas.openxmlformats.org/drawingml/2006/chart">
+            <c:chart xmlns:c="http://schemas.openxmlformats.org/drawingml/2006/chart" r:id="rId1"/>
+          </a:graphicData>
+        </a:graphic>
+      </p:graphicFrame>
     </p:spTree>
   </p:cSld>
   <p:clrMapOvr>
@@ -3841,7 +5884,7 @@
     <a:fontScheme name="Office">
       <a:majorFont>
         <a:latin typeface="Calibri Light" panose="020F0302020204030204"/>
-        <a:ea typeface=""/>
+        <a:ea typeface="Microsoft YaHei"/>
         <a:cs typeface=""/>
         <a:font script="Jpan" typeface="游ゴシック Light"/>
         <a:font script="Hang" typeface="맑은 고딕"/>
@@ -3893,7 +5936,7 @@
       </a:majorFont>
       <a:minorFont>
         <a:latin typeface="Calibri" panose="020F0502020204030204"/>
-        <a:ea typeface=""/>
+        <a:ea typeface="Microsoft YaHei"/>
         <a:cs typeface=""/>
         <a:font script="Jpan" typeface="游ゴシック"/>
         <a:font script="Hang" typeface="맑은 고딕"/>

</xml_diff>